<commit_message>
small update lisdes bgt and ut
</commit_message>
<xml_diff>
--- a/slides/ut.pptx
+++ b/slides/ut.pptx
@@ -311,7 +311,7 @@
               <a:pPr>
                 <a:defRPr/>
               </a:pPr>
-              <a:t>20-04-2026</a:t>
+              <a:t>23-04-2026</a:t>
             </a:fld>
             <a:endParaRPr lang="en-US"/>
           </a:p>
@@ -979,7 +979,7 @@
               <a:pPr>
                 <a:defRPr/>
               </a:pPr>
-              <a:t>37</a:t>
+              <a:t>35</a:t>
             </a:fld>
             <a:endParaRPr lang="en-US"/>
           </a:p>
@@ -988,7 +988,7 @@
     </p:spTree>
     <p:extLst>
       <p:ext uri="{BB962C8B-B14F-4D97-AF65-F5344CB8AC3E}">
-        <p14:creationId xmlns:p14="http://schemas.microsoft.com/office/powerpoint/2010/main" val="3120005148"/>
+        <p14:creationId xmlns:p14="http://schemas.microsoft.com/office/powerpoint/2010/main" val="1065686508"/>
       </p:ext>
     </p:extLst>
   </p:cSld>
@@ -1069,7 +1069,7 @@
               <a:pPr>
                 <a:defRPr/>
               </a:pPr>
-              <a:t>38</a:t>
+              <a:t>37</a:t>
             </a:fld>
             <a:endParaRPr lang="en-US"/>
           </a:p>
@@ -1078,7 +1078,7 @@
     </p:spTree>
     <p:extLst>
       <p:ext uri="{BB962C8B-B14F-4D97-AF65-F5344CB8AC3E}">
-        <p14:creationId xmlns:p14="http://schemas.microsoft.com/office/powerpoint/2010/main" val="468100708"/>
+        <p14:creationId xmlns:p14="http://schemas.microsoft.com/office/powerpoint/2010/main" val="3120005148"/>
       </p:ext>
     </p:extLst>
   </p:cSld>
@@ -1159,7 +1159,7 @@
               <a:pPr>
                 <a:defRPr/>
               </a:pPr>
-              <a:t>40</a:t>
+              <a:t>38</a:t>
             </a:fld>
             <a:endParaRPr lang="en-US"/>
           </a:p>
@@ -1168,7 +1168,7 @@
     </p:spTree>
     <p:extLst>
       <p:ext uri="{BB962C8B-B14F-4D97-AF65-F5344CB8AC3E}">
-        <p14:creationId xmlns:p14="http://schemas.microsoft.com/office/powerpoint/2010/main" val="3726015562"/>
+        <p14:creationId xmlns:p14="http://schemas.microsoft.com/office/powerpoint/2010/main" val="468100708"/>
       </p:ext>
     </p:extLst>
   </p:cSld>
@@ -1222,7 +1222,7 @@
           <a:bodyPr/>
           <a:lstStyle/>
           <a:p>
-            <a:endParaRPr lang="en-US" dirty="0"/>
+            <a:endParaRPr lang="en-NL" dirty="0"/>
           </a:p>
         </p:txBody>
       </p:sp>
@@ -1233,7 +1233,7 @@
             <a:spLocks noGrp="1"/>
           </p:cNvSpPr>
           <p:nvPr>
-            <p:ph type="sldNum" sz="quarter" idx="10"/>
+            <p:ph type="sldNum" sz="quarter" idx="5"/>
           </p:nvPr>
         </p:nvSpPr>
         <p:spPr/>
@@ -1249,7 +1249,7 @@
               <a:pPr>
                 <a:defRPr/>
               </a:pPr>
-              <a:t>41</a:t>
+              <a:t>40</a:t>
             </a:fld>
             <a:endParaRPr lang="en-US"/>
           </a:p>
@@ -1258,7 +1258,7 @@
     </p:spTree>
     <p:extLst>
       <p:ext uri="{BB962C8B-B14F-4D97-AF65-F5344CB8AC3E}">
-        <p14:creationId xmlns:p14="http://schemas.microsoft.com/office/powerpoint/2010/main" val="640978486"/>
+        <p14:creationId xmlns:p14="http://schemas.microsoft.com/office/powerpoint/2010/main" val="3726015562"/>
       </p:ext>
     </p:extLst>
   </p:cSld>
@@ -1312,30 +1312,7 @@
           <a:bodyPr/>
           <a:lstStyle/>
           <a:p>
-            <a:pPr marL="0" marR="0" lvl="0" indent="0" algn="l" defTabSz="914400" rtl="0" eaLnBrk="0" fontAlgn="base" latinLnBrk="0" hangingPunct="0">
-              <a:lnSpc>
-                <a:spcPct val="100000"/>
-              </a:lnSpc>
-              <a:spcBef>
-                <a:spcPct val="30000"/>
-              </a:spcBef>
-              <a:spcAft>
-                <a:spcPct val="0"/>
-              </a:spcAft>
-              <a:buClrTx/>
-              <a:buSzTx/>
-              <a:buFontTx/>
-              <a:buNone/>
-              <a:tabLst/>
-              <a:defRPr/>
-            </a:pPr>
-            <a:r>
-              <a:rPr lang="en-US" dirty="0"/>
-              <a:t>In the literature, testing a program by exploiting relations of multiple methods/operations like in the example above is also called “metamorphic testing”</a:t>
-            </a:r>
-          </a:p>
-          <a:p>
-            <a:endParaRPr lang="en-NL" dirty="0"/>
+            <a:endParaRPr lang="en-US" dirty="0"/>
           </a:p>
         </p:txBody>
       </p:sp>
@@ -1346,7 +1323,7 @@
             <a:spLocks noGrp="1"/>
           </p:cNvSpPr>
           <p:nvPr>
-            <p:ph type="sldNum" sz="quarter" idx="5"/>
+            <p:ph type="sldNum" sz="quarter" idx="10"/>
           </p:nvPr>
         </p:nvSpPr>
         <p:spPr/>
@@ -1362,7 +1339,7 @@
               <a:pPr>
                 <a:defRPr/>
               </a:pPr>
-              <a:t>42</a:t>
+              <a:t>41</a:t>
             </a:fld>
             <a:endParaRPr lang="en-US"/>
           </a:p>
@@ -1371,7 +1348,7 @@
     </p:spTree>
     <p:extLst>
       <p:ext uri="{BB962C8B-B14F-4D97-AF65-F5344CB8AC3E}">
-        <p14:creationId xmlns:p14="http://schemas.microsoft.com/office/powerpoint/2010/main" val="3478692827"/>
+        <p14:creationId xmlns:p14="http://schemas.microsoft.com/office/powerpoint/2010/main" val="640978486"/>
       </p:ext>
     </p:extLst>
   </p:cSld>
@@ -1400,29 +1377,19 @@
       </p:grpSpPr>
       <p:sp>
         <p:nvSpPr>
-          <p:cNvPr id="55298" name="Slide Image Placeholder 1"/>
+          <p:cNvPr id="2" name="Slide Image Placeholder 1"/>
           <p:cNvSpPr>
-            <a:spLocks noGrp="1" noRot="1" noChangeAspect="1" noTextEdit="1"/>
+            <a:spLocks noGrp="1" noRot="1" noChangeAspect="1"/>
           </p:cNvSpPr>
           <p:nvPr>
             <p:ph type="sldImg"/>
           </p:nvPr>
         </p:nvSpPr>
-        <p:spPr bwMode="auto">
-          <a:noFill/>
-          <a:ln>
-            <a:solidFill>
-              <a:srgbClr val="000000"/>
-            </a:solidFill>
-            <a:miter lim="800000"/>
-            <a:headEnd/>
-            <a:tailEnd/>
-          </a:ln>
-        </p:spPr>
-      </p:sp>
-      <p:sp>
-        <p:nvSpPr>
-          <p:cNvPr id="55299" name="Notes Placeholder 2"/>
+        <p:spPr/>
+      </p:sp>
+      <p:sp>
+        <p:nvSpPr>
+          <p:cNvPr id="3" name="Notes Placeholder 2"/>
           <p:cNvSpPr>
             <a:spLocks noGrp="1"/>
           </p:cNvSpPr>
@@ -1430,21 +1397,35 @@
             <p:ph type="body" idx="1"/>
           </p:nvPr>
         </p:nvSpPr>
-        <p:spPr bwMode="auto">
-          <a:noFill/>
-        </p:spPr>
-        <p:txBody>
-          <a:bodyPr wrap="square" numCol="1" anchor="t" anchorCtr="0" compatLnSpc="1">
-            <a:prstTxWarp prst="textNoShape">
-              <a:avLst/>
-            </a:prstTxWarp>
-          </a:bodyPr>
-          <a:lstStyle/>
-          <a:p>
-            <a:endParaRPr lang="en-US" dirty="0"/>
-          </a:p>
-          <a:p>
-            <a:endParaRPr lang="en-US" dirty="0"/>
+        <p:spPr/>
+        <p:txBody>
+          <a:bodyPr/>
+          <a:lstStyle/>
+          <a:p>
+            <a:pPr marL="0" marR="0" lvl="0" indent="0" algn="l" defTabSz="914400" rtl="0" eaLnBrk="0" fontAlgn="base" latinLnBrk="0" hangingPunct="0">
+              <a:lnSpc>
+                <a:spcPct val="100000"/>
+              </a:lnSpc>
+              <a:spcBef>
+                <a:spcPct val="30000"/>
+              </a:spcBef>
+              <a:spcAft>
+                <a:spcPct val="0"/>
+              </a:spcAft>
+              <a:buClrTx/>
+              <a:buSzTx/>
+              <a:buFontTx/>
+              <a:buNone/>
+              <a:tabLst/>
+              <a:defRPr/>
+            </a:pPr>
+            <a:r>
+              <a:rPr lang="en-US" dirty="0"/>
+              <a:t>In the literature, testing a program by exploiting relations of multiple methods/operations like in the example above is also called “metamorphic testing”</a:t>
+            </a:r>
+          </a:p>
+          <a:p>
+            <a:endParaRPr lang="en-NL" dirty="0"/>
           </a:p>
         </p:txBody>
       </p:sp>
@@ -1466,12 +1447,12 @@
             <a:pPr>
               <a:defRPr/>
             </a:pPr>
-            <a:fld id="{EC5B1458-9BA2-4FCA-B083-2E2B2AD6D16B}" type="slidenum">
+            <a:fld id="{F84EA20E-9838-494E-B9DD-2C988F7E650A}" type="slidenum">
               <a:rPr lang="en-US" smtClean="0"/>
               <a:pPr>
                 <a:defRPr/>
               </a:pPr>
-              <a:t>44</a:t>
+              <a:t>42</a:t>
             </a:fld>
             <a:endParaRPr lang="en-US"/>
           </a:p>
@@ -1480,7 +1461,7 @@
     </p:spTree>
     <p:extLst>
       <p:ext uri="{BB962C8B-B14F-4D97-AF65-F5344CB8AC3E}">
-        <p14:creationId xmlns:p14="http://schemas.microsoft.com/office/powerpoint/2010/main" val="1763036822"/>
+        <p14:creationId xmlns:p14="http://schemas.microsoft.com/office/powerpoint/2010/main" val="3478692827"/>
       </p:ext>
     </p:extLst>
   </p:cSld>
@@ -1550,45 +1531,6 @@
           </a:bodyPr>
           <a:lstStyle/>
           <a:p>
-            <a:pPr marL="0" marR="0" lvl="0" indent="0" algn="l" defTabSz="914400" rtl="0" eaLnBrk="0" fontAlgn="base" latinLnBrk="0" hangingPunct="0">
-              <a:lnSpc>
-                <a:spcPct val="100000"/>
-              </a:lnSpc>
-              <a:spcBef>
-                <a:spcPct val="30000"/>
-              </a:spcBef>
-              <a:spcAft>
-                <a:spcPct val="0"/>
-              </a:spcAft>
-              <a:buClrTx/>
-              <a:buSzTx/>
-              <a:buFontTx/>
-              <a:buNone/>
-              <a:tabLst/>
-              <a:defRPr/>
-            </a:pPr>
-            <a:r>
-              <a:rPr lang="en-US" dirty="0"/>
-              <a:t>There are other mock framework for .NET, e.g. </a:t>
-            </a:r>
-            <a:r>
-              <a:rPr lang="en-US" dirty="0" err="1"/>
-              <a:t>Moq</a:t>
-            </a:r>
-            <a:r>
-              <a:rPr lang="en-US" dirty="0"/>
-              <a:t>, rhino, </a:t>
-            </a:r>
-            <a:r>
-              <a:rPr lang="en-US" dirty="0" err="1"/>
-              <a:t>easymock</a:t>
-            </a:r>
-            <a:r>
-              <a:rPr lang="en-US" dirty="0"/>
-              <a:t>, etc. </a:t>
-            </a:r>
-          </a:p>
-          <a:p>
             <a:endParaRPr lang="en-US" dirty="0"/>
           </a:p>
           <a:p>
@@ -1619,7 +1561,7 @@
               <a:pPr>
                 <a:defRPr/>
               </a:pPr>
-              <a:t>45</a:t>
+              <a:t>44</a:t>
             </a:fld>
             <a:endParaRPr lang="en-US"/>
           </a:p>
@@ -1628,7 +1570,7 @@
     </p:spTree>
     <p:extLst>
       <p:ext uri="{BB962C8B-B14F-4D97-AF65-F5344CB8AC3E}">
-        <p14:creationId xmlns:p14="http://schemas.microsoft.com/office/powerpoint/2010/main" val="791692650"/>
+        <p14:creationId xmlns:p14="http://schemas.microsoft.com/office/powerpoint/2010/main" val="1763036822"/>
       </p:ext>
     </p:extLst>
   </p:cSld>
@@ -1657,19 +1599,29 @@
       </p:grpSpPr>
       <p:sp>
         <p:nvSpPr>
-          <p:cNvPr id="2" name="Slide Image Placeholder 1"/>
+          <p:cNvPr id="55298" name="Slide Image Placeholder 1"/>
           <p:cNvSpPr>
-            <a:spLocks noGrp="1" noRot="1" noChangeAspect="1"/>
+            <a:spLocks noGrp="1" noRot="1" noChangeAspect="1" noTextEdit="1"/>
           </p:cNvSpPr>
           <p:nvPr>
             <p:ph type="sldImg"/>
           </p:nvPr>
         </p:nvSpPr>
-        <p:spPr/>
-      </p:sp>
-      <p:sp>
-        <p:nvSpPr>
-          <p:cNvPr id="3" name="Notes Placeholder 2"/>
+        <p:spPr bwMode="auto">
+          <a:noFill/>
+          <a:ln>
+            <a:solidFill>
+              <a:srgbClr val="000000"/>
+            </a:solidFill>
+            <a:miter lim="800000"/>
+            <a:headEnd/>
+            <a:tailEnd/>
+          </a:ln>
+        </p:spPr>
+      </p:sp>
+      <p:sp>
+        <p:nvSpPr>
+          <p:cNvPr id="55299" name="Notes Placeholder 2"/>
           <p:cNvSpPr>
             <a:spLocks noGrp="1"/>
           </p:cNvSpPr>
@@ -1677,666 +1629,53 @@
             <p:ph type="body" idx="1"/>
           </p:nvPr>
         </p:nvSpPr>
-        <p:spPr/>
-        <p:txBody>
-          <a:bodyPr>
-            <a:normAutofit fontScale="77500" lnSpcReduction="20000"/>
+        <p:spPr bwMode="auto">
+          <a:noFill/>
+        </p:spPr>
+        <p:txBody>
+          <a:bodyPr wrap="square" numCol="1" anchor="t" anchorCtr="0" compatLnSpc="1">
+            <a:prstTxWarp prst="textNoShape">
+              <a:avLst/>
+            </a:prstTxWarp>
           </a:bodyPr>
           <a:lstStyle/>
           <a:p>
+            <a:pPr marL="0" marR="0" lvl="0" indent="0" algn="l" defTabSz="914400" rtl="0" eaLnBrk="0" fontAlgn="base" latinLnBrk="0" hangingPunct="0">
+              <a:lnSpc>
+                <a:spcPct val="100000"/>
+              </a:lnSpc>
+              <a:spcBef>
+                <a:spcPct val="30000"/>
+              </a:spcBef>
+              <a:spcAft>
+                <a:spcPct val="0"/>
+              </a:spcAft>
+              <a:buClrTx/>
+              <a:buSzTx/>
+              <a:buFontTx/>
+              <a:buNone/>
+              <a:tabLst/>
+              <a:defRPr/>
+            </a:pPr>
             <a:r>
               <a:rPr lang="en-US" dirty="0"/>
-              <a:t>Note:</a:t>
-            </a:r>
-          </a:p>
-          <a:p>
-            <a:endParaRPr lang="en-US" dirty="0"/>
-          </a:p>
-          <a:p>
+              <a:t>There are other mock framework for .NET, e.g. </a:t>
+            </a:r>
+            <a:r>
+              <a:rPr lang="en-US" dirty="0" err="1"/>
+              <a:t>Moq</a:t>
+            </a:r>
             <a:r>
               <a:rPr lang="en-US" dirty="0"/>
-              <a:t>The method “For&lt;I&gt;()” creates an instance of I. </a:t>
-            </a:r>
-          </a:p>
-          <a:p>
-            <a:endParaRPr lang="en-US" dirty="0"/>
-          </a:p>
-          <a:p>
+              <a:t>, rhino, </a:t>
+            </a:r>
+            <a:r>
+              <a:rPr lang="en-US" dirty="0" err="1"/>
+              <a:t>easymock</a:t>
+            </a:r>
             <a:r>
               <a:rPr lang="en-US" dirty="0"/>
-              <a:t>The method “Returns” is probably more magical, especially for Java programmer. E.g. in the above example the method “value(x)” of </a:t>
-            </a:r>
-            <a:r>
-              <a:rPr lang="en-US" dirty="0" err="1"/>
-              <a:t>IThremometer</a:t>
-            </a:r>
-            <a:r>
-              <a:rPr lang="en-US" dirty="0"/>
-              <a:t> returns a “double”. Now, in C# primitives like double are also objects. </a:t>
-            </a:r>
-          </a:p>
-          <a:p>
-            <a:endParaRPr lang="en-US" dirty="0"/>
-          </a:p>
-          <a:p>
-            <a:r>
-              <a:rPr lang="en-US" dirty="0"/>
-              <a:t>Furthermore C# allows a class, including primitives, to be “method-extended”. Normal class can be sub-classed. But primitives and sealed classes cannot be sub-classed. However, C# allows a syntactic sugar called “extension method”. Example with extending string:</a:t>
-            </a:r>
-          </a:p>
-          <a:p>
-            <a:endParaRPr lang="en-US" dirty="0"/>
-          </a:p>
-          <a:p>
-            <a:r>
-              <a:rPr lang="en-US" sz="1200" b="1" i="0" kern="1200" dirty="0">
-                <a:solidFill>
-                  <a:schemeClr val="tx1"/>
-                </a:solidFill>
-                <a:effectLst/>
-                <a:latin typeface="+mn-lt"/>
-                <a:ea typeface="+mn-ea"/>
-                <a:cs typeface="+mn-cs"/>
-              </a:rPr>
-              <a:t>static</a:t>
-            </a:r>
-            <a:r>
-              <a:rPr lang="en-US" sz="1200" b="0" i="0" kern="1200" dirty="0">
-                <a:solidFill>
-                  <a:schemeClr val="tx1"/>
-                </a:solidFill>
-                <a:effectLst/>
-                <a:latin typeface="+mn-lt"/>
-                <a:ea typeface="+mn-ea"/>
-                <a:cs typeface="+mn-cs"/>
-              </a:rPr>
-              <a:t> </a:t>
-            </a:r>
-            <a:r>
-              <a:rPr lang="en-US" sz="1200" b="1" i="0" kern="1200" dirty="0">
-                <a:solidFill>
-                  <a:schemeClr val="tx1"/>
-                </a:solidFill>
-                <a:effectLst/>
-                <a:latin typeface="+mn-lt"/>
-                <a:ea typeface="+mn-ea"/>
-                <a:cs typeface="+mn-cs"/>
-              </a:rPr>
-              <a:t>class</a:t>
-            </a:r>
-            <a:r>
-              <a:rPr lang="en-US" sz="1200" b="0" i="0" kern="1200" dirty="0">
-                <a:solidFill>
-                  <a:schemeClr val="tx1"/>
-                </a:solidFill>
-                <a:effectLst/>
-                <a:latin typeface="+mn-lt"/>
-                <a:ea typeface="+mn-ea"/>
-                <a:cs typeface="+mn-cs"/>
-              </a:rPr>
-              <a:t>  Extensions  </a:t>
-            </a:r>
-          </a:p>
-          <a:p>
-            <a:r>
-              <a:rPr lang="en-US" sz="1200" b="0" i="0" kern="1200" dirty="0">
-                <a:solidFill>
-                  <a:schemeClr val="tx1"/>
-                </a:solidFill>
-                <a:effectLst/>
-                <a:latin typeface="+mn-lt"/>
-                <a:ea typeface="+mn-ea"/>
-                <a:cs typeface="+mn-cs"/>
-              </a:rPr>
-              <a:t>    {  </a:t>
-            </a:r>
-          </a:p>
-          <a:p>
-            <a:r>
-              <a:rPr lang="en-US" sz="1200" b="0" i="0" kern="1200" dirty="0">
-                <a:solidFill>
-                  <a:schemeClr val="tx1"/>
-                </a:solidFill>
-                <a:effectLst/>
-                <a:latin typeface="+mn-lt"/>
-                <a:ea typeface="+mn-ea"/>
-                <a:cs typeface="+mn-cs"/>
-              </a:rPr>
-              <a:t>        </a:t>
-            </a:r>
-            <a:r>
-              <a:rPr lang="en-US" sz="1200" b="1" i="0" kern="1200" dirty="0">
-                <a:solidFill>
-                  <a:schemeClr val="tx1"/>
-                </a:solidFill>
-                <a:effectLst/>
-                <a:latin typeface="+mn-lt"/>
-                <a:ea typeface="+mn-ea"/>
-                <a:cs typeface="+mn-cs"/>
-              </a:rPr>
-              <a:t>public</a:t>
-            </a:r>
-            <a:r>
-              <a:rPr lang="en-US" sz="1200" b="0" i="0" kern="1200" dirty="0">
-                <a:solidFill>
-                  <a:schemeClr val="tx1"/>
-                </a:solidFill>
-                <a:effectLst/>
-                <a:latin typeface="+mn-lt"/>
-                <a:ea typeface="+mn-ea"/>
-                <a:cs typeface="+mn-cs"/>
-              </a:rPr>
-              <a:t> </a:t>
-            </a:r>
-            <a:r>
-              <a:rPr lang="en-US" sz="1200" b="1" i="0" kern="1200" dirty="0">
-                <a:solidFill>
-                  <a:schemeClr val="tx1"/>
-                </a:solidFill>
-                <a:effectLst/>
-                <a:latin typeface="+mn-lt"/>
-                <a:ea typeface="+mn-ea"/>
-                <a:cs typeface="+mn-cs"/>
-              </a:rPr>
-              <a:t>static</a:t>
-            </a:r>
-            <a:r>
-              <a:rPr lang="en-US" sz="1200" b="0" i="0" kern="1200" dirty="0">
-                <a:solidFill>
-                  <a:schemeClr val="tx1"/>
-                </a:solidFill>
-                <a:effectLst/>
-                <a:latin typeface="+mn-lt"/>
-                <a:ea typeface="+mn-ea"/>
-                <a:cs typeface="+mn-cs"/>
-              </a:rPr>
-              <a:t> </a:t>
-            </a:r>
-            <a:r>
-              <a:rPr lang="en-US" sz="1200" b="1" i="0" kern="1200" dirty="0">
-                <a:solidFill>
-                  <a:schemeClr val="tx1"/>
-                </a:solidFill>
-                <a:effectLst/>
-                <a:latin typeface="+mn-lt"/>
-                <a:ea typeface="+mn-ea"/>
-                <a:cs typeface="+mn-cs"/>
-              </a:rPr>
-              <a:t>string</a:t>
-            </a:r>
-            <a:r>
-              <a:rPr lang="en-US" sz="1200" b="0" i="0" kern="1200" dirty="0">
-                <a:solidFill>
-                  <a:schemeClr val="tx1"/>
-                </a:solidFill>
-                <a:effectLst/>
-                <a:latin typeface="+mn-lt"/>
-                <a:ea typeface="+mn-ea"/>
-                <a:cs typeface="+mn-cs"/>
-              </a:rPr>
-              <a:t> </a:t>
-            </a:r>
-            <a:r>
-              <a:rPr lang="en-US" sz="1200" b="0" i="0" kern="1200" dirty="0" err="1">
-                <a:solidFill>
-                  <a:schemeClr val="tx1"/>
-                </a:solidFill>
-                <a:effectLst/>
-                <a:latin typeface="+mn-lt"/>
-                <a:ea typeface="+mn-ea"/>
-                <a:cs typeface="+mn-cs"/>
-              </a:rPr>
-              <a:t>UpperFirst</a:t>
-            </a:r>
-            <a:r>
-              <a:rPr lang="en-US" sz="1200" b="0" i="0" kern="1200" dirty="0">
-                <a:solidFill>
-                  <a:schemeClr val="tx1"/>
-                </a:solidFill>
-                <a:effectLst/>
-                <a:latin typeface="+mn-lt"/>
-                <a:ea typeface="+mn-ea"/>
-                <a:cs typeface="+mn-cs"/>
-              </a:rPr>
-              <a:t>(</a:t>
-            </a:r>
-            <a:r>
-              <a:rPr lang="en-US" sz="1200" b="1" i="0" kern="1200" dirty="0">
-                <a:solidFill>
-                  <a:schemeClr val="tx1"/>
-                </a:solidFill>
-                <a:effectLst/>
-                <a:latin typeface="+mn-lt"/>
-                <a:ea typeface="+mn-ea"/>
-                <a:cs typeface="+mn-cs"/>
-              </a:rPr>
-              <a:t>this</a:t>
-            </a:r>
-            <a:r>
-              <a:rPr lang="en-US" sz="1200" b="0" i="0" kern="1200" dirty="0">
-                <a:solidFill>
-                  <a:schemeClr val="tx1"/>
-                </a:solidFill>
-                <a:effectLst/>
-                <a:latin typeface="+mn-lt"/>
-                <a:ea typeface="+mn-ea"/>
-                <a:cs typeface="+mn-cs"/>
-              </a:rPr>
-              <a:t> String </a:t>
-            </a:r>
-            <a:r>
-              <a:rPr lang="en-US" sz="1200" b="0" i="0" kern="1200" dirty="0" err="1">
-                <a:solidFill>
-                  <a:schemeClr val="tx1"/>
-                </a:solidFill>
-                <a:effectLst/>
-                <a:latin typeface="+mn-lt"/>
-                <a:ea typeface="+mn-ea"/>
-                <a:cs typeface="+mn-cs"/>
-              </a:rPr>
-              <a:t>str</a:t>
-            </a:r>
-            <a:r>
-              <a:rPr lang="en-US" sz="1200" b="0" i="0" kern="1200" dirty="0">
-                <a:solidFill>
-                  <a:schemeClr val="tx1"/>
-                </a:solidFill>
-                <a:effectLst/>
-                <a:latin typeface="+mn-lt"/>
-                <a:ea typeface="+mn-ea"/>
-                <a:cs typeface="+mn-cs"/>
-              </a:rPr>
-              <a:t>)  </a:t>
-            </a:r>
-          </a:p>
-          <a:p>
-            <a:r>
-              <a:rPr lang="en-US" sz="1200" b="0" i="0" kern="1200" dirty="0">
-                <a:solidFill>
-                  <a:schemeClr val="tx1"/>
-                </a:solidFill>
-                <a:effectLst/>
-                <a:latin typeface="+mn-lt"/>
-                <a:ea typeface="+mn-ea"/>
-                <a:cs typeface="+mn-cs"/>
-              </a:rPr>
-              <a:t>        {  </a:t>
-            </a:r>
-          </a:p>
-          <a:p>
-            <a:r>
-              <a:rPr lang="en-US" sz="1200" b="0" i="0" kern="1200" dirty="0">
-                <a:solidFill>
-                  <a:schemeClr val="tx1"/>
-                </a:solidFill>
-                <a:effectLst/>
-                <a:latin typeface="+mn-lt"/>
-                <a:ea typeface="+mn-ea"/>
-                <a:cs typeface="+mn-cs"/>
-              </a:rPr>
-              <a:t>            </a:t>
-            </a:r>
-            <a:r>
-              <a:rPr lang="en-US" sz="1200" b="1" i="0" kern="1200" dirty="0">
-                <a:solidFill>
-                  <a:schemeClr val="tx1"/>
-                </a:solidFill>
-                <a:effectLst/>
-                <a:latin typeface="+mn-lt"/>
-                <a:ea typeface="+mn-ea"/>
-                <a:cs typeface="+mn-cs"/>
-              </a:rPr>
-              <a:t>if</a:t>
-            </a:r>
-            <a:r>
-              <a:rPr lang="en-US" sz="1200" b="0" i="0" kern="1200" dirty="0">
-                <a:solidFill>
-                  <a:schemeClr val="tx1"/>
-                </a:solidFill>
-                <a:effectLst/>
-                <a:latin typeface="+mn-lt"/>
-                <a:ea typeface="+mn-ea"/>
-                <a:cs typeface="+mn-cs"/>
-              </a:rPr>
-              <a:t> (</a:t>
-            </a:r>
-            <a:r>
-              <a:rPr lang="en-US" sz="1200" b="0" i="0" kern="1200" dirty="0" err="1">
-                <a:solidFill>
-                  <a:schemeClr val="tx1"/>
-                </a:solidFill>
-                <a:effectLst/>
-                <a:latin typeface="+mn-lt"/>
-                <a:ea typeface="+mn-ea"/>
-                <a:cs typeface="+mn-cs"/>
-              </a:rPr>
-              <a:t>String.IsNullOrEmpty</a:t>
-            </a:r>
-            <a:r>
-              <a:rPr lang="en-US" sz="1200" b="0" i="0" kern="1200" dirty="0">
-                <a:solidFill>
-                  <a:schemeClr val="tx1"/>
-                </a:solidFill>
-                <a:effectLst/>
-                <a:latin typeface="+mn-lt"/>
-                <a:ea typeface="+mn-ea"/>
-                <a:cs typeface="+mn-cs"/>
-              </a:rPr>
-              <a:t>(</a:t>
-            </a:r>
-            <a:r>
-              <a:rPr lang="en-US" sz="1200" b="0" i="0" kern="1200" dirty="0" err="1">
-                <a:solidFill>
-                  <a:schemeClr val="tx1"/>
-                </a:solidFill>
-                <a:effectLst/>
-                <a:latin typeface="+mn-lt"/>
-                <a:ea typeface="+mn-ea"/>
-                <a:cs typeface="+mn-cs"/>
-              </a:rPr>
-              <a:t>str</a:t>
-            </a:r>
-            <a:r>
-              <a:rPr lang="en-US" sz="1200" b="0" i="0" kern="1200" dirty="0">
-                <a:solidFill>
-                  <a:schemeClr val="tx1"/>
-                </a:solidFill>
-                <a:effectLst/>
-                <a:latin typeface="+mn-lt"/>
-                <a:ea typeface="+mn-ea"/>
-                <a:cs typeface="+mn-cs"/>
-              </a:rPr>
-              <a:t>))  </a:t>
-            </a:r>
-          </a:p>
-          <a:p>
-            <a:r>
-              <a:rPr lang="en-US" sz="1200" b="0" i="0" kern="1200" dirty="0">
-                <a:solidFill>
-                  <a:schemeClr val="tx1"/>
-                </a:solidFill>
-                <a:effectLst/>
-                <a:latin typeface="+mn-lt"/>
-                <a:ea typeface="+mn-ea"/>
-                <a:cs typeface="+mn-cs"/>
-              </a:rPr>
-              <a:t>                </a:t>
-            </a:r>
-            <a:r>
-              <a:rPr lang="en-US" sz="1200" b="1" i="0" kern="1200" dirty="0">
-                <a:solidFill>
-                  <a:schemeClr val="tx1"/>
-                </a:solidFill>
-                <a:effectLst/>
-                <a:latin typeface="+mn-lt"/>
-                <a:ea typeface="+mn-ea"/>
-                <a:cs typeface="+mn-cs"/>
-              </a:rPr>
-              <a:t>return</a:t>
-            </a:r>
-            <a:r>
-              <a:rPr lang="en-US" sz="1200" b="0" i="0" kern="1200" dirty="0">
-                <a:solidFill>
-                  <a:schemeClr val="tx1"/>
-                </a:solidFill>
-                <a:effectLst/>
-                <a:latin typeface="+mn-lt"/>
-                <a:ea typeface="+mn-ea"/>
-                <a:cs typeface="+mn-cs"/>
-              </a:rPr>
-              <a:t> </a:t>
-            </a:r>
-            <a:r>
-              <a:rPr lang="en-US" sz="1200" b="0" i="0" kern="1200" dirty="0" err="1">
-                <a:solidFill>
-                  <a:schemeClr val="tx1"/>
-                </a:solidFill>
-                <a:effectLst/>
-                <a:latin typeface="+mn-lt"/>
-                <a:ea typeface="+mn-ea"/>
-                <a:cs typeface="+mn-cs"/>
-              </a:rPr>
-              <a:t>String.Empty</a:t>
-            </a:r>
-            <a:r>
-              <a:rPr lang="en-US" sz="1200" b="0" i="0" kern="1200" dirty="0">
-                <a:solidFill>
-                  <a:schemeClr val="tx1"/>
-                </a:solidFill>
-                <a:effectLst/>
-                <a:latin typeface="+mn-lt"/>
-                <a:ea typeface="+mn-ea"/>
-                <a:cs typeface="+mn-cs"/>
-              </a:rPr>
-              <a:t>;  </a:t>
-            </a:r>
-          </a:p>
-          <a:p>
-            <a:r>
-              <a:rPr lang="en-US" sz="1200" b="0" i="0" kern="1200" dirty="0">
-                <a:solidFill>
-                  <a:schemeClr val="tx1"/>
-                </a:solidFill>
-                <a:effectLst/>
-                <a:latin typeface="+mn-lt"/>
-                <a:ea typeface="+mn-ea"/>
-                <a:cs typeface="+mn-cs"/>
-              </a:rPr>
-              <a:t>  </a:t>
-            </a:r>
-          </a:p>
-          <a:p>
-            <a:r>
-              <a:rPr lang="en-US" sz="1200" b="0" i="0" kern="1200" dirty="0">
-                <a:solidFill>
-                  <a:schemeClr val="tx1"/>
-                </a:solidFill>
-                <a:effectLst/>
-                <a:latin typeface="+mn-lt"/>
-                <a:ea typeface="+mn-ea"/>
-                <a:cs typeface="+mn-cs"/>
-              </a:rPr>
-              <a:t>            </a:t>
-            </a:r>
-            <a:r>
-              <a:rPr lang="en-US" sz="1200" b="1" i="0" kern="1200" dirty="0">
-                <a:solidFill>
-                  <a:schemeClr val="tx1"/>
-                </a:solidFill>
-                <a:effectLst/>
-                <a:latin typeface="+mn-lt"/>
-                <a:ea typeface="+mn-ea"/>
-                <a:cs typeface="+mn-cs"/>
-              </a:rPr>
-              <a:t>return</a:t>
-            </a:r>
-            <a:r>
-              <a:rPr lang="en-US" sz="1200" b="0" i="0" kern="1200" dirty="0">
-                <a:solidFill>
-                  <a:schemeClr val="tx1"/>
-                </a:solidFill>
-                <a:effectLst/>
-                <a:latin typeface="+mn-lt"/>
-                <a:ea typeface="+mn-ea"/>
-                <a:cs typeface="+mn-cs"/>
-              </a:rPr>
-              <a:t> </a:t>
-            </a:r>
-            <a:r>
-              <a:rPr lang="en-US" sz="1200" b="0" i="0" kern="1200" dirty="0" err="1">
-                <a:solidFill>
-                  <a:schemeClr val="tx1"/>
-                </a:solidFill>
-                <a:effectLst/>
-                <a:latin typeface="+mn-lt"/>
-                <a:ea typeface="+mn-ea"/>
-                <a:cs typeface="+mn-cs"/>
-              </a:rPr>
-              <a:t>str.Substring</a:t>
-            </a:r>
-            <a:r>
-              <a:rPr lang="en-US" sz="1200" b="0" i="0" kern="1200" dirty="0">
-                <a:solidFill>
-                  <a:schemeClr val="tx1"/>
-                </a:solidFill>
-                <a:effectLst/>
-                <a:latin typeface="+mn-lt"/>
-                <a:ea typeface="+mn-ea"/>
-                <a:cs typeface="+mn-cs"/>
-              </a:rPr>
-              <a:t>(0, 1).</a:t>
-            </a:r>
-            <a:r>
-              <a:rPr lang="en-US" sz="1200" b="0" i="0" kern="1200" dirty="0" err="1">
-                <a:solidFill>
-                  <a:schemeClr val="tx1"/>
-                </a:solidFill>
-                <a:effectLst/>
-                <a:latin typeface="+mn-lt"/>
-                <a:ea typeface="+mn-ea"/>
-                <a:cs typeface="+mn-cs"/>
-              </a:rPr>
-              <a:t>ToUpper</a:t>
-            </a:r>
-            <a:r>
-              <a:rPr lang="en-US" sz="1200" b="0" i="0" kern="1200" dirty="0">
-                <a:solidFill>
-                  <a:schemeClr val="tx1"/>
-                </a:solidFill>
-                <a:effectLst/>
-                <a:latin typeface="+mn-lt"/>
-                <a:ea typeface="+mn-ea"/>
-                <a:cs typeface="+mn-cs"/>
-              </a:rPr>
-              <a:t>() + </a:t>
-            </a:r>
-            <a:r>
-              <a:rPr lang="en-US" sz="1200" b="0" i="0" kern="1200" dirty="0" err="1">
-                <a:solidFill>
-                  <a:schemeClr val="tx1"/>
-                </a:solidFill>
-                <a:effectLst/>
-                <a:latin typeface="+mn-lt"/>
-                <a:ea typeface="+mn-ea"/>
-                <a:cs typeface="+mn-cs"/>
-              </a:rPr>
-              <a:t>str.Substring</a:t>
-            </a:r>
-            <a:r>
-              <a:rPr lang="en-US" sz="1200" b="0" i="0" kern="1200" dirty="0">
-                <a:solidFill>
-                  <a:schemeClr val="tx1"/>
-                </a:solidFill>
-                <a:effectLst/>
-                <a:latin typeface="+mn-lt"/>
-                <a:ea typeface="+mn-ea"/>
-                <a:cs typeface="+mn-cs"/>
-              </a:rPr>
-              <a:t>(1, str.Length-1).</a:t>
-            </a:r>
-            <a:r>
-              <a:rPr lang="en-US" sz="1200" b="0" i="0" kern="1200" dirty="0" err="1">
-                <a:solidFill>
-                  <a:schemeClr val="tx1"/>
-                </a:solidFill>
-                <a:effectLst/>
-                <a:latin typeface="+mn-lt"/>
-                <a:ea typeface="+mn-ea"/>
-                <a:cs typeface="+mn-cs"/>
-              </a:rPr>
-              <a:t>ToLower</a:t>
-            </a:r>
-            <a:r>
-              <a:rPr lang="en-US" sz="1200" b="0" i="0" kern="1200" dirty="0">
-                <a:solidFill>
-                  <a:schemeClr val="tx1"/>
-                </a:solidFill>
-                <a:effectLst/>
-                <a:latin typeface="+mn-lt"/>
-                <a:ea typeface="+mn-ea"/>
-                <a:cs typeface="+mn-cs"/>
-              </a:rPr>
-              <a:t>();  </a:t>
-            </a:r>
-          </a:p>
-          <a:p>
-            <a:r>
-              <a:rPr lang="en-US" sz="1200" b="0" i="0" kern="1200" dirty="0">
-                <a:solidFill>
-                  <a:schemeClr val="tx1"/>
-                </a:solidFill>
-                <a:effectLst/>
-                <a:latin typeface="+mn-lt"/>
-                <a:ea typeface="+mn-ea"/>
-                <a:cs typeface="+mn-cs"/>
-              </a:rPr>
-              <a:t>        }  </a:t>
-            </a:r>
-          </a:p>
-          <a:p>
-            <a:r>
-              <a:rPr lang="en-US" sz="1200" b="0" i="0" kern="1200" dirty="0">
-                <a:solidFill>
-                  <a:schemeClr val="tx1"/>
-                </a:solidFill>
-                <a:effectLst/>
-                <a:latin typeface="+mn-lt"/>
-                <a:ea typeface="+mn-ea"/>
-                <a:cs typeface="+mn-cs"/>
-              </a:rPr>
-              <a:t>    }  </a:t>
-            </a:r>
-          </a:p>
-          <a:p>
-            <a:endParaRPr lang="en-US" dirty="0"/>
-          </a:p>
-          <a:p>
-            <a:r>
-              <a:rPr lang="en-US" dirty="0"/>
-              <a:t>Having this in the scope, we can now write:</a:t>
-            </a:r>
-            <a:br>
-              <a:rPr lang="en-US" dirty="0"/>
-            </a:br>
-            <a:br>
-              <a:rPr lang="en-US" dirty="0"/>
-            </a:br>
-            <a:r>
-              <a:rPr lang="en-US" dirty="0"/>
-              <a:t>   String z = “hello”</a:t>
-            </a:r>
-            <a:br>
-              <a:rPr lang="en-US" dirty="0"/>
-            </a:br>
-            <a:r>
-              <a:rPr lang="en-US" dirty="0"/>
-              <a:t>    z = </a:t>
-            </a:r>
-            <a:r>
-              <a:rPr lang="en-US" dirty="0" err="1"/>
-              <a:t>z.UpperFirst</a:t>
-            </a:r>
-            <a:r>
-              <a:rPr lang="en-US" dirty="0"/>
-              <a:t>()</a:t>
-            </a:r>
-            <a:br>
-              <a:rPr lang="en-US" dirty="0"/>
-            </a:br>
-            <a:br>
-              <a:rPr lang="en-US" dirty="0"/>
-            </a:br>
-            <a:r>
-              <a:rPr lang="en-US" dirty="0"/>
-              <a:t>So what </a:t>
-            </a:r>
-            <a:r>
-              <a:rPr lang="en-US" dirty="0" err="1"/>
-              <a:t>NSubstutute</a:t>
-            </a:r>
-            <a:r>
-              <a:rPr lang="en-US" dirty="0"/>
-              <a:t> does is likely to extend return types of mocked methods, including primitives, with the method “Returns”.</a:t>
+              <a:t>, etc. </a:t>
             </a:r>
           </a:p>
           <a:p>
@@ -2365,12 +1704,12 @@
             <a:pPr>
               <a:defRPr/>
             </a:pPr>
-            <a:fld id="{F84EA20E-9838-494E-B9DD-2C988F7E650A}" type="slidenum">
+            <a:fld id="{EC5B1458-9BA2-4FCA-B083-2E2B2AD6D16B}" type="slidenum">
               <a:rPr lang="en-US" smtClean="0"/>
               <a:pPr>
                 <a:defRPr/>
               </a:pPr>
-              <a:t>46</a:t>
+              <a:t>45</a:t>
             </a:fld>
             <a:endParaRPr lang="en-US"/>
           </a:p>
@@ -2379,7 +1718,7 @@
     </p:spTree>
     <p:extLst>
       <p:ext uri="{BB962C8B-B14F-4D97-AF65-F5344CB8AC3E}">
-        <p14:creationId xmlns:p14="http://schemas.microsoft.com/office/powerpoint/2010/main" val="812723745"/>
+        <p14:creationId xmlns:p14="http://schemas.microsoft.com/office/powerpoint/2010/main" val="791692650"/>
       </p:ext>
     </p:extLst>
   </p:cSld>
@@ -2569,6 +1908,757 @@
 </file>
 
 <file path=ppt/notesSlides/notesSlide20.xml><?xml version="1.0" encoding="utf-8"?>
+<p:notes xmlns:a="http://schemas.openxmlformats.org/drawingml/2006/main" xmlns:r="http://schemas.openxmlformats.org/officeDocument/2006/relationships" xmlns:p="http://schemas.openxmlformats.org/presentationml/2006/main">
+  <p:cSld>
+    <p:spTree>
+      <p:nvGrpSpPr>
+        <p:cNvPr id="1" name=""/>
+        <p:cNvGrpSpPr/>
+        <p:nvPr/>
+      </p:nvGrpSpPr>
+      <p:grpSpPr>
+        <a:xfrm>
+          <a:off x="0" y="0"/>
+          <a:ext cx="0" cy="0"/>
+          <a:chOff x="0" y="0"/>
+          <a:chExt cx="0" cy="0"/>
+        </a:xfrm>
+      </p:grpSpPr>
+      <p:sp>
+        <p:nvSpPr>
+          <p:cNvPr id="2" name="Slide Image Placeholder 1"/>
+          <p:cNvSpPr>
+            <a:spLocks noGrp="1" noRot="1" noChangeAspect="1"/>
+          </p:cNvSpPr>
+          <p:nvPr>
+            <p:ph type="sldImg"/>
+          </p:nvPr>
+        </p:nvSpPr>
+        <p:spPr/>
+      </p:sp>
+      <p:sp>
+        <p:nvSpPr>
+          <p:cNvPr id="3" name="Notes Placeholder 2"/>
+          <p:cNvSpPr>
+            <a:spLocks noGrp="1"/>
+          </p:cNvSpPr>
+          <p:nvPr>
+            <p:ph type="body" idx="1"/>
+          </p:nvPr>
+        </p:nvSpPr>
+        <p:spPr/>
+        <p:txBody>
+          <a:bodyPr>
+            <a:normAutofit fontScale="77500" lnSpcReduction="20000"/>
+          </a:bodyPr>
+          <a:lstStyle/>
+          <a:p>
+            <a:r>
+              <a:rPr lang="en-US" dirty="0"/>
+              <a:t>Note:</a:t>
+            </a:r>
+          </a:p>
+          <a:p>
+            <a:endParaRPr lang="en-US" dirty="0"/>
+          </a:p>
+          <a:p>
+            <a:r>
+              <a:rPr lang="en-US" dirty="0"/>
+              <a:t>The method “For&lt;I&gt;()” creates an instance of I. </a:t>
+            </a:r>
+          </a:p>
+          <a:p>
+            <a:endParaRPr lang="en-US" dirty="0"/>
+          </a:p>
+          <a:p>
+            <a:r>
+              <a:rPr lang="en-US" dirty="0"/>
+              <a:t>The method “Returns” is probably more magical, especially for Java programmer. E.g. in the above example the method “value(x)” of </a:t>
+            </a:r>
+            <a:r>
+              <a:rPr lang="en-US" dirty="0" err="1"/>
+              <a:t>IThremometer</a:t>
+            </a:r>
+            <a:r>
+              <a:rPr lang="en-US" dirty="0"/>
+              <a:t> returns a “double”. Now, in C# primitives like double are also objects. </a:t>
+            </a:r>
+          </a:p>
+          <a:p>
+            <a:endParaRPr lang="en-US" dirty="0"/>
+          </a:p>
+          <a:p>
+            <a:r>
+              <a:rPr lang="en-US" dirty="0"/>
+              <a:t>Furthermore C# allows a class, including primitives, to be “method-extended”. Normal class can be sub-classed. But primitives and sealed classes cannot be sub-classed. However, C# allows a syntactic sugar called “extension method”. Example with extending string:</a:t>
+            </a:r>
+          </a:p>
+          <a:p>
+            <a:endParaRPr lang="en-US" dirty="0"/>
+          </a:p>
+          <a:p>
+            <a:r>
+              <a:rPr lang="en-US" sz="1200" b="1" i="0" kern="1200" dirty="0">
+                <a:solidFill>
+                  <a:schemeClr val="tx1"/>
+                </a:solidFill>
+                <a:effectLst/>
+                <a:latin typeface="+mn-lt"/>
+                <a:ea typeface="+mn-ea"/>
+                <a:cs typeface="+mn-cs"/>
+              </a:rPr>
+              <a:t>static</a:t>
+            </a:r>
+            <a:r>
+              <a:rPr lang="en-US" sz="1200" b="0" i="0" kern="1200" dirty="0">
+                <a:solidFill>
+                  <a:schemeClr val="tx1"/>
+                </a:solidFill>
+                <a:effectLst/>
+                <a:latin typeface="+mn-lt"/>
+                <a:ea typeface="+mn-ea"/>
+                <a:cs typeface="+mn-cs"/>
+              </a:rPr>
+              <a:t> </a:t>
+            </a:r>
+            <a:r>
+              <a:rPr lang="en-US" sz="1200" b="1" i="0" kern="1200" dirty="0">
+                <a:solidFill>
+                  <a:schemeClr val="tx1"/>
+                </a:solidFill>
+                <a:effectLst/>
+                <a:latin typeface="+mn-lt"/>
+                <a:ea typeface="+mn-ea"/>
+                <a:cs typeface="+mn-cs"/>
+              </a:rPr>
+              <a:t>class</a:t>
+            </a:r>
+            <a:r>
+              <a:rPr lang="en-US" sz="1200" b="0" i="0" kern="1200" dirty="0">
+                <a:solidFill>
+                  <a:schemeClr val="tx1"/>
+                </a:solidFill>
+                <a:effectLst/>
+                <a:latin typeface="+mn-lt"/>
+                <a:ea typeface="+mn-ea"/>
+                <a:cs typeface="+mn-cs"/>
+              </a:rPr>
+              <a:t>  Extensions  </a:t>
+            </a:r>
+          </a:p>
+          <a:p>
+            <a:r>
+              <a:rPr lang="en-US" sz="1200" b="0" i="0" kern="1200" dirty="0">
+                <a:solidFill>
+                  <a:schemeClr val="tx1"/>
+                </a:solidFill>
+                <a:effectLst/>
+                <a:latin typeface="+mn-lt"/>
+                <a:ea typeface="+mn-ea"/>
+                <a:cs typeface="+mn-cs"/>
+              </a:rPr>
+              <a:t>    {  </a:t>
+            </a:r>
+          </a:p>
+          <a:p>
+            <a:r>
+              <a:rPr lang="en-US" sz="1200" b="0" i="0" kern="1200" dirty="0">
+                <a:solidFill>
+                  <a:schemeClr val="tx1"/>
+                </a:solidFill>
+                <a:effectLst/>
+                <a:latin typeface="+mn-lt"/>
+                <a:ea typeface="+mn-ea"/>
+                <a:cs typeface="+mn-cs"/>
+              </a:rPr>
+              <a:t>        </a:t>
+            </a:r>
+            <a:r>
+              <a:rPr lang="en-US" sz="1200" b="1" i="0" kern="1200" dirty="0">
+                <a:solidFill>
+                  <a:schemeClr val="tx1"/>
+                </a:solidFill>
+                <a:effectLst/>
+                <a:latin typeface="+mn-lt"/>
+                <a:ea typeface="+mn-ea"/>
+                <a:cs typeface="+mn-cs"/>
+              </a:rPr>
+              <a:t>public</a:t>
+            </a:r>
+            <a:r>
+              <a:rPr lang="en-US" sz="1200" b="0" i="0" kern="1200" dirty="0">
+                <a:solidFill>
+                  <a:schemeClr val="tx1"/>
+                </a:solidFill>
+                <a:effectLst/>
+                <a:latin typeface="+mn-lt"/>
+                <a:ea typeface="+mn-ea"/>
+                <a:cs typeface="+mn-cs"/>
+              </a:rPr>
+              <a:t> </a:t>
+            </a:r>
+            <a:r>
+              <a:rPr lang="en-US" sz="1200" b="1" i="0" kern="1200" dirty="0">
+                <a:solidFill>
+                  <a:schemeClr val="tx1"/>
+                </a:solidFill>
+                <a:effectLst/>
+                <a:latin typeface="+mn-lt"/>
+                <a:ea typeface="+mn-ea"/>
+                <a:cs typeface="+mn-cs"/>
+              </a:rPr>
+              <a:t>static</a:t>
+            </a:r>
+            <a:r>
+              <a:rPr lang="en-US" sz="1200" b="0" i="0" kern="1200" dirty="0">
+                <a:solidFill>
+                  <a:schemeClr val="tx1"/>
+                </a:solidFill>
+                <a:effectLst/>
+                <a:latin typeface="+mn-lt"/>
+                <a:ea typeface="+mn-ea"/>
+                <a:cs typeface="+mn-cs"/>
+              </a:rPr>
+              <a:t> </a:t>
+            </a:r>
+            <a:r>
+              <a:rPr lang="en-US" sz="1200" b="1" i="0" kern="1200" dirty="0">
+                <a:solidFill>
+                  <a:schemeClr val="tx1"/>
+                </a:solidFill>
+                <a:effectLst/>
+                <a:latin typeface="+mn-lt"/>
+                <a:ea typeface="+mn-ea"/>
+                <a:cs typeface="+mn-cs"/>
+              </a:rPr>
+              <a:t>string</a:t>
+            </a:r>
+            <a:r>
+              <a:rPr lang="en-US" sz="1200" b="0" i="0" kern="1200" dirty="0">
+                <a:solidFill>
+                  <a:schemeClr val="tx1"/>
+                </a:solidFill>
+                <a:effectLst/>
+                <a:latin typeface="+mn-lt"/>
+                <a:ea typeface="+mn-ea"/>
+                <a:cs typeface="+mn-cs"/>
+              </a:rPr>
+              <a:t> </a:t>
+            </a:r>
+            <a:r>
+              <a:rPr lang="en-US" sz="1200" b="0" i="0" kern="1200" dirty="0" err="1">
+                <a:solidFill>
+                  <a:schemeClr val="tx1"/>
+                </a:solidFill>
+                <a:effectLst/>
+                <a:latin typeface="+mn-lt"/>
+                <a:ea typeface="+mn-ea"/>
+                <a:cs typeface="+mn-cs"/>
+              </a:rPr>
+              <a:t>UpperFirst</a:t>
+            </a:r>
+            <a:r>
+              <a:rPr lang="en-US" sz="1200" b="0" i="0" kern="1200" dirty="0">
+                <a:solidFill>
+                  <a:schemeClr val="tx1"/>
+                </a:solidFill>
+                <a:effectLst/>
+                <a:latin typeface="+mn-lt"/>
+                <a:ea typeface="+mn-ea"/>
+                <a:cs typeface="+mn-cs"/>
+              </a:rPr>
+              <a:t>(</a:t>
+            </a:r>
+            <a:r>
+              <a:rPr lang="en-US" sz="1200" b="1" i="0" kern="1200" dirty="0">
+                <a:solidFill>
+                  <a:schemeClr val="tx1"/>
+                </a:solidFill>
+                <a:effectLst/>
+                <a:latin typeface="+mn-lt"/>
+                <a:ea typeface="+mn-ea"/>
+                <a:cs typeface="+mn-cs"/>
+              </a:rPr>
+              <a:t>this</a:t>
+            </a:r>
+            <a:r>
+              <a:rPr lang="en-US" sz="1200" b="0" i="0" kern="1200" dirty="0">
+                <a:solidFill>
+                  <a:schemeClr val="tx1"/>
+                </a:solidFill>
+                <a:effectLst/>
+                <a:latin typeface="+mn-lt"/>
+                <a:ea typeface="+mn-ea"/>
+                <a:cs typeface="+mn-cs"/>
+              </a:rPr>
+              <a:t> String </a:t>
+            </a:r>
+            <a:r>
+              <a:rPr lang="en-US" sz="1200" b="0" i="0" kern="1200" dirty="0" err="1">
+                <a:solidFill>
+                  <a:schemeClr val="tx1"/>
+                </a:solidFill>
+                <a:effectLst/>
+                <a:latin typeface="+mn-lt"/>
+                <a:ea typeface="+mn-ea"/>
+                <a:cs typeface="+mn-cs"/>
+              </a:rPr>
+              <a:t>str</a:t>
+            </a:r>
+            <a:r>
+              <a:rPr lang="en-US" sz="1200" b="0" i="0" kern="1200" dirty="0">
+                <a:solidFill>
+                  <a:schemeClr val="tx1"/>
+                </a:solidFill>
+                <a:effectLst/>
+                <a:latin typeface="+mn-lt"/>
+                <a:ea typeface="+mn-ea"/>
+                <a:cs typeface="+mn-cs"/>
+              </a:rPr>
+              <a:t>)  </a:t>
+            </a:r>
+          </a:p>
+          <a:p>
+            <a:r>
+              <a:rPr lang="en-US" sz="1200" b="0" i="0" kern="1200" dirty="0">
+                <a:solidFill>
+                  <a:schemeClr val="tx1"/>
+                </a:solidFill>
+                <a:effectLst/>
+                <a:latin typeface="+mn-lt"/>
+                <a:ea typeface="+mn-ea"/>
+                <a:cs typeface="+mn-cs"/>
+              </a:rPr>
+              <a:t>        {  </a:t>
+            </a:r>
+          </a:p>
+          <a:p>
+            <a:r>
+              <a:rPr lang="en-US" sz="1200" b="0" i="0" kern="1200" dirty="0">
+                <a:solidFill>
+                  <a:schemeClr val="tx1"/>
+                </a:solidFill>
+                <a:effectLst/>
+                <a:latin typeface="+mn-lt"/>
+                <a:ea typeface="+mn-ea"/>
+                <a:cs typeface="+mn-cs"/>
+              </a:rPr>
+              <a:t>            </a:t>
+            </a:r>
+            <a:r>
+              <a:rPr lang="en-US" sz="1200" b="1" i="0" kern="1200" dirty="0">
+                <a:solidFill>
+                  <a:schemeClr val="tx1"/>
+                </a:solidFill>
+                <a:effectLst/>
+                <a:latin typeface="+mn-lt"/>
+                <a:ea typeface="+mn-ea"/>
+                <a:cs typeface="+mn-cs"/>
+              </a:rPr>
+              <a:t>if</a:t>
+            </a:r>
+            <a:r>
+              <a:rPr lang="en-US" sz="1200" b="0" i="0" kern="1200" dirty="0">
+                <a:solidFill>
+                  <a:schemeClr val="tx1"/>
+                </a:solidFill>
+                <a:effectLst/>
+                <a:latin typeface="+mn-lt"/>
+                <a:ea typeface="+mn-ea"/>
+                <a:cs typeface="+mn-cs"/>
+              </a:rPr>
+              <a:t> (</a:t>
+            </a:r>
+            <a:r>
+              <a:rPr lang="en-US" sz="1200" b="0" i="0" kern="1200" dirty="0" err="1">
+                <a:solidFill>
+                  <a:schemeClr val="tx1"/>
+                </a:solidFill>
+                <a:effectLst/>
+                <a:latin typeface="+mn-lt"/>
+                <a:ea typeface="+mn-ea"/>
+                <a:cs typeface="+mn-cs"/>
+              </a:rPr>
+              <a:t>String.IsNullOrEmpty</a:t>
+            </a:r>
+            <a:r>
+              <a:rPr lang="en-US" sz="1200" b="0" i="0" kern="1200" dirty="0">
+                <a:solidFill>
+                  <a:schemeClr val="tx1"/>
+                </a:solidFill>
+                <a:effectLst/>
+                <a:latin typeface="+mn-lt"/>
+                <a:ea typeface="+mn-ea"/>
+                <a:cs typeface="+mn-cs"/>
+              </a:rPr>
+              <a:t>(</a:t>
+            </a:r>
+            <a:r>
+              <a:rPr lang="en-US" sz="1200" b="0" i="0" kern="1200" dirty="0" err="1">
+                <a:solidFill>
+                  <a:schemeClr val="tx1"/>
+                </a:solidFill>
+                <a:effectLst/>
+                <a:latin typeface="+mn-lt"/>
+                <a:ea typeface="+mn-ea"/>
+                <a:cs typeface="+mn-cs"/>
+              </a:rPr>
+              <a:t>str</a:t>
+            </a:r>
+            <a:r>
+              <a:rPr lang="en-US" sz="1200" b="0" i="0" kern="1200" dirty="0">
+                <a:solidFill>
+                  <a:schemeClr val="tx1"/>
+                </a:solidFill>
+                <a:effectLst/>
+                <a:latin typeface="+mn-lt"/>
+                <a:ea typeface="+mn-ea"/>
+                <a:cs typeface="+mn-cs"/>
+              </a:rPr>
+              <a:t>))  </a:t>
+            </a:r>
+          </a:p>
+          <a:p>
+            <a:r>
+              <a:rPr lang="en-US" sz="1200" b="0" i="0" kern="1200" dirty="0">
+                <a:solidFill>
+                  <a:schemeClr val="tx1"/>
+                </a:solidFill>
+                <a:effectLst/>
+                <a:latin typeface="+mn-lt"/>
+                <a:ea typeface="+mn-ea"/>
+                <a:cs typeface="+mn-cs"/>
+              </a:rPr>
+              <a:t>                </a:t>
+            </a:r>
+            <a:r>
+              <a:rPr lang="en-US" sz="1200" b="1" i="0" kern="1200" dirty="0">
+                <a:solidFill>
+                  <a:schemeClr val="tx1"/>
+                </a:solidFill>
+                <a:effectLst/>
+                <a:latin typeface="+mn-lt"/>
+                <a:ea typeface="+mn-ea"/>
+                <a:cs typeface="+mn-cs"/>
+              </a:rPr>
+              <a:t>return</a:t>
+            </a:r>
+            <a:r>
+              <a:rPr lang="en-US" sz="1200" b="0" i="0" kern="1200" dirty="0">
+                <a:solidFill>
+                  <a:schemeClr val="tx1"/>
+                </a:solidFill>
+                <a:effectLst/>
+                <a:latin typeface="+mn-lt"/>
+                <a:ea typeface="+mn-ea"/>
+                <a:cs typeface="+mn-cs"/>
+              </a:rPr>
+              <a:t> </a:t>
+            </a:r>
+            <a:r>
+              <a:rPr lang="en-US" sz="1200" b="0" i="0" kern="1200" dirty="0" err="1">
+                <a:solidFill>
+                  <a:schemeClr val="tx1"/>
+                </a:solidFill>
+                <a:effectLst/>
+                <a:latin typeface="+mn-lt"/>
+                <a:ea typeface="+mn-ea"/>
+                <a:cs typeface="+mn-cs"/>
+              </a:rPr>
+              <a:t>String.Empty</a:t>
+            </a:r>
+            <a:r>
+              <a:rPr lang="en-US" sz="1200" b="0" i="0" kern="1200" dirty="0">
+                <a:solidFill>
+                  <a:schemeClr val="tx1"/>
+                </a:solidFill>
+                <a:effectLst/>
+                <a:latin typeface="+mn-lt"/>
+                <a:ea typeface="+mn-ea"/>
+                <a:cs typeface="+mn-cs"/>
+              </a:rPr>
+              <a:t>;  </a:t>
+            </a:r>
+          </a:p>
+          <a:p>
+            <a:r>
+              <a:rPr lang="en-US" sz="1200" b="0" i="0" kern="1200" dirty="0">
+                <a:solidFill>
+                  <a:schemeClr val="tx1"/>
+                </a:solidFill>
+                <a:effectLst/>
+                <a:latin typeface="+mn-lt"/>
+                <a:ea typeface="+mn-ea"/>
+                <a:cs typeface="+mn-cs"/>
+              </a:rPr>
+              <a:t>  </a:t>
+            </a:r>
+          </a:p>
+          <a:p>
+            <a:r>
+              <a:rPr lang="en-US" sz="1200" b="0" i="0" kern="1200" dirty="0">
+                <a:solidFill>
+                  <a:schemeClr val="tx1"/>
+                </a:solidFill>
+                <a:effectLst/>
+                <a:latin typeface="+mn-lt"/>
+                <a:ea typeface="+mn-ea"/>
+                <a:cs typeface="+mn-cs"/>
+              </a:rPr>
+              <a:t>            </a:t>
+            </a:r>
+            <a:r>
+              <a:rPr lang="en-US" sz="1200" b="1" i="0" kern="1200" dirty="0">
+                <a:solidFill>
+                  <a:schemeClr val="tx1"/>
+                </a:solidFill>
+                <a:effectLst/>
+                <a:latin typeface="+mn-lt"/>
+                <a:ea typeface="+mn-ea"/>
+                <a:cs typeface="+mn-cs"/>
+              </a:rPr>
+              <a:t>return</a:t>
+            </a:r>
+            <a:r>
+              <a:rPr lang="en-US" sz="1200" b="0" i="0" kern="1200" dirty="0">
+                <a:solidFill>
+                  <a:schemeClr val="tx1"/>
+                </a:solidFill>
+                <a:effectLst/>
+                <a:latin typeface="+mn-lt"/>
+                <a:ea typeface="+mn-ea"/>
+                <a:cs typeface="+mn-cs"/>
+              </a:rPr>
+              <a:t> </a:t>
+            </a:r>
+            <a:r>
+              <a:rPr lang="en-US" sz="1200" b="0" i="0" kern="1200" dirty="0" err="1">
+                <a:solidFill>
+                  <a:schemeClr val="tx1"/>
+                </a:solidFill>
+                <a:effectLst/>
+                <a:latin typeface="+mn-lt"/>
+                <a:ea typeface="+mn-ea"/>
+                <a:cs typeface="+mn-cs"/>
+              </a:rPr>
+              <a:t>str.Substring</a:t>
+            </a:r>
+            <a:r>
+              <a:rPr lang="en-US" sz="1200" b="0" i="0" kern="1200" dirty="0">
+                <a:solidFill>
+                  <a:schemeClr val="tx1"/>
+                </a:solidFill>
+                <a:effectLst/>
+                <a:latin typeface="+mn-lt"/>
+                <a:ea typeface="+mn-ea"/>
+                <a:cs typeface="+mn-cs"/>
+              </a:rPr>
+              <a:t>(0, 1).</a:t>
+            </a:r>
+            <a:r>
+              <a:rPr lang="en-US" sz="1200" b="0" i="0" kern="1200" dirty="0" err="1">
+                <a:solidFill>
+                  <a:schemeClr val="tx1"/>
+                </a:solidFill>
+                <a:effectLst/>
+                <a:latin typeface="+mn-lt"/>
+                <a:ea typeface="+mn-ea"/>
+                <a:cs typeface="+mn-cs"/>
+              </a:rPr>
+              <a:t>ToUpper</a:t>
+            </a:r>
+            <a:r>
+              <a:rPr lang="en-US" sz="1200" b="0" i="0" kern="1200" dirty="0">
+                <a:solidFill>
+                  <a:schemeClr val="tx1"/>
+                </a:solidFill>
+                <a:effectLst/>
+                <a:latin typeface="+mn-lt"/>
+                <a:ea typeface="+mn-ea"/>
+                <a:cs typeface="+mn-cs"/>
+              </a:rPr>
+              <a:t>() + </a:t>
+            </a:r>
+            <a:r>
+              <a:rPr lang="en-US" sz="1200" b="0" i="0" kern="1200" dirty="0" err="1">
+                <a:solidFill>
+                  <a:schemeClr val="tx1"/>
+                </a:solidFill>
+                <a:effectLst/>
+                <a:latin typeface="+mn-lt"/>
+                <a:ea typeface="+mn-ea"/>
+                <a:cs typeface="+mn-cs"/>
+              </a:rPr>
+              <a:t>str.Substring</a:t>
+            </a:r>
+            <a:r>
+              <a:rPr lang="en-US" sz="1200" b="0" i="0" kern="1200" dirty="0">
+                <a:solidFill>
+                  <a:schemeClr val="tx1"/>
+                </a:solidFill>
+                <a:effectLst/>
+                <a:latin typeface="+mn-lt"/>
+                <a:ea typeface="+mn-ea"/>
+                <a:cs typeface="+mn-cs"/>
+              </a:rPr>
+              <a:t>(1, str.Length-1).</a:t>
+            </a:r>
+            <a:r>
+              <a:rPr lang="en-US" sz="1200" b="0" i="0" kern="1200" dirty="0" err="1">
+                <a:solidFill>
+                  <a:schemeClr val="tx1"/>
+                </a:solidFill>
+                <a:effectLst/>
+                <a:latin typeface="+mn-lt"/>
+                <a:ea typeface="+mn-ea"/>
+                <a:cs typeface="+mn-cs"/>
+              </a:rPr>
+              <a:t>ToLower</a:t>
+            </a:r>
+            <a:r>
+              <a:rPr lang="en-US" sz="1200" b="0" i="0" kern="1200" dirty="0">
+                <a:solidFill>
+                  <a:schemeClr val="tx1"/>
+                </a:solidFill>
+                <a:effectLst/>
+                <a:latin typeface="+mn-lt"/>
+                <a:ea typeface="+mn-ea"/>
+                <a:cs typeface="+mn-cs"/>
+              </a:rPr>
+              <a:t>();  </a:t>
+            </a:r>
+          </a:p>
+          <a:p>
+            <a:r>
+              <a:rPr lang="en-US" sz="1200" b="0" i="0" kern="1200" dirty="0">
+                <a:solidFill>
+                  <a:schemeClr val="tx1"/>
+                </a:solidFill>
+                <a:effectLst/>
+                <a:latin typeface="+mn-lt"/>
+                <a:ea typeface="+mn-ea"/>
+                <a:cs typeface="+mn-cs"/>
+              </a:rPr>
+              <a:t>        }  </a:t>
+            </a:r>
+          </a:p>
+          <a:p>
+            <a:r>
+              <a:rPr lang="en-US" sz="1200" b="0" i="0" kern="1200" dirty="0">
+                <a:solidFill>
+                  <a:schemeClr val="tx1"/>
+                </a:solidFill>
+                <a:effectLst/>
+                <a:latin typeface="+mn-lt"/>
+                <a:ea typeface="+mn-ea"/>
+                <a:cs typeface="+mn-cs"/>
+              </a:rPr>
+              <a:t>    }  </a:t>
+            </a:r>
+          </a:p>
+          <a:p>
+            <a:endParaRPr lang="en-US" dirty="0"/>
+          </a:p>
+          <a:p>
+            <a:r>
+              <a:rPr lang="en-US" dirty="0"/>
+              <a:t>Having this in the scope, we can now write:</a:t>
+            </a:r>
+            <a:br>
+              <a:rPr lang="en-US" dirty="0"/>
+            </a:br>
+            <a:br>
+              <a:rPr lang="en-US" dirty="0"/>
+            </a:br>
+            <a:r>
+              <a:rPr lang="en-US" dirty="0"/>
+              <a:t>   String z = “hello”</a:t>
+            </a:r>
+            <a:br>
+              <a:rPr lang="en-US" dirty="0"/>
+            </a:br>
+            <a:r>
+              <a:rPr lang="en-US" dirty="0"/>
+              <a:t>    z = </a:t>
+            </a:r>
+            <a:r>
+              <a:rPr lang="en-US" dirty="0" err="1"/>
+              <a:t>z.UpperFirst</a:t>
+            </a:r>
+            <a:r>
+              <a:rPr lang="en-US" dirty="0"/>
+              <a:t>()</a:t>
+            </a:r>
+            <a:br>
+              <a:rPr lang="en-US" dirty="0"/>
+            </a:br>
+            <a:br>
+              <a:rPr lang="en-US" dirty="0"/>
+            </a:br>
+            <a:r>
+              <a:rPr lang="en-US" dirty="0"/>
+              <a:t>So what </a:t>
+            </a:r>
+            <a:r>
+              <a:rPr lang="en-US" dirty="0" err="1"/>
+              <a:t>NSubstutute</a:t>
+            </a:r>
+            <a:r>
+              <a:rPr lang="en-US" dirty="0"/>
+              <a:t> does is likely to extend return types of mocked methods, including primitives, with the method “Returns”.</a:t>
+            </a:r>
+          </a:p>
+          <a:p>
+            <a:endParaRPr lang="en-US" dirty="0"/>
+          </a:p>
+          <a:p>
+            <a:endParaRPr lang="en-US" dirty="0"/>
+          </a:p>
+        </p:txBody>
+      </p:sp>
+      <p:sp>
+        <p:nvSpPr>
+          <p:cNvPr id="4" name="Slide Number Placeholder 3"/>
+          <p:cNvSpPr>
+            <a:spLocks noGrp="1"/>
+          </p:cNvSpPr>
+          <p:nvPr>
+            <p:ph type="sldNum" sz="quarter" idx="5"/>
+          </p:nvPr>
+        </p:nvSpPr>
+        <p:spPr/>
+        <p:txBody>
+          <a:bodyPr/>
+          <a:lstStyle/>
+          <a:p>
+            <a:pPr>
+              <a:defRPr/>
+            </a:pPr>
+            <a:fld id="{F84EA20E-9838-494E-B9DD-2C988F7E650A}" type="slidenum">
+              <a:rPr lang="en-US" smtClean="0"/>
+              <a:pPr>
+                <a:defRPr/>
+              </a:pPr>
+              <a:t>46</a:t>
+            </a:fld>
+            <a:endParaRPr lang="en-US"/>
+          </a:p>
+        </p:txBody>
+      </p:sp>
+    </p:spTree>
+    <p:extLst>
+      <p:ext uri="{BB962C8B-B14F-4D97-AF65-F5344CB8AC3E}">
+        <p14:creationId xmlns:p14="http://schemas.microsoft.com/office/powerpoint/2010/main" val="812723745"/>
+      </p:ext>
+    </p:extLst>
+  </p:cSld>
+  <p:clrMapOvr>
+    <a:masterClrMapping/>
+  </p:clrMapOvr>
+</p:notes>
+</file>
+
+<file path=ppt/notesSlides/notesSlide21.xml><?xml version="1.0" encoding="utf-8"?>
 <p:notes xmlns:a="http://schemas.openxmlformats.org/drawingml/2006/main" xmlns:r="http://schemas.openxmlformats.org/officeDocument/2006/relationships" xmlns:p="http://schemas.openxmlformats.org/presentationml/2006/main">
   <p:cSld>
     <p:spTree>
@@ -3686,7 +3776,7 @@
               <a:pPr>
                 <a:defRPr/>
               </a:pPr>
-              <a:t>20-04-2026</a:t>
+              <a:t>23-04-2026</a:t>
             </a:fld>
             <a:endParaRPr lang="en-US"/>
           </a:p>
@@ -3876,7 +3966,7 @@
               <a:pPr>
                 <a:defRPr/>
               </a:pPr>
-              <a:t>20-04-2026</a:t>
+              <a:t>23-04-2026</a:t>
             </a:fld>
             <a:endParaRPr lang="en-US"/>
           </a:p>
@@ -4076,7 +4166,7 @@
               <a:pPr>
                 <a:defRPr/>
               </a:pPr>
-              <a:t>20-04-2026</a:t>
+              <a:t>23-04-2026</a:t>
             </a:fld>
             <a:endParaRPr lang="en-US"/>
           </a:p>
@@ -4272,7 +4362,7 @@
               <a:pPr>
                 <a:defRPr/>
               </a:pPr>
-              <a:t>20-04-2026</a:t>
+              <a:t>23-04-2026</a:t>
             </a:fld>
             <a:endParaRPr lang="en-US"/>
           </a:p>
@@ -4539,7 +4629,7 @@
               <a:pPr>
                 <a:defRPr/>
               </a:pPr>
-              <a:t>20-04-2026</a:t>
+              <a:t>23-04-2026</a:t>
             </a:fld>
             <a:endParaRPr lang="en-US"/>
           </a:p>
@@ -4846,7 +4936,7 @@
               <a:pPr>
                 <a:defRPr/>
               </a:pPr>
-              <a:t>20-04-2026</a:t>
+              <a:t>23-04-2026</a:t>
             </a:fld>
             <a:endParaRPr lang="en-US"/>
           </a:p>
@@ -5287,7 +5377,7 @@
               <a:pPr>
                 <a:defRPr/>
               </a:pPr>
-              <a:t>20-04-2026</a:t>
+              <a:t>23-04-2026</a:t>
             </a:fld>
             <a:endParaRPr lang="en-US"/>
           </a:p>
@@ -5432,7 +5522,7 @@
               <a:pPr>
                 <a:defRPr/>
               </a:pPr>
-              <a:t>20-04-2026</a:t>
+              <a:t>23-04-2026</a:t>
             </a:fld>
             <a:endParaRPr lang="en-US"/>
           </a:p>
@@ -5549,7 +5639,7 @@
               <a:pPr>
                 <a:defRPr/>
               </a:pPr>
-              <a:t>20-04-2026</a:t>
+              <a:t>23-04-2026</a:t>
             </a:fld>
             <a:endParaRPr lang="en-US"/>
           </a:p>
@@ -5846,7 +5936,7 @@
               <a:pPr>
                 <a:defRPr/>
               </a:pPr>
-              <a:t>20-04-2026</a:t>
+              <a:t>23-04-2026</a:t>
             </a:fld>
             <a:endParaRPr lang="en-US"/>
           </a:p>
@@ -6126,7 +6216,7 @@
               <a:pPr>
                 <a:defRPr/>
               </a:pPr>
-              <a:t>20-04-2026</a:t>
+              <a:t>23-04-2026</a:t>
             </a:fld>
             <a:endParaRPr lang="en-US"/>
           </a:p>
@@ -6382,7 +6472,7 @@
               <a:pPr>
                 <a:defRPr/>
               </a:pPr>
-              <a:t>20-04-2026</a:t>
+              <a:t>23-04-2026</a:t>
             </a:fld>
             <a:endParaRPr lang="en-US"/>
           </a:p>
@@ -16724,16 +16814,23 @@
               </a:rPr>
               <a:t>specify every method with pre- and post-conditions (we discussed this).</a:t>
             </a:r>
-            <a:br>
-              <a:rPr lang="en-US" sz="2800" dirty="0">
+          </a:p>
+          <a:p>
+            <a:pPr lvl="1" eaLnBrk="1" hangingPunct="1"/>
+            <a:r>
+              <a:rPr lang="en-US" sz="2400" dirty="0">
                 <a:sym typeface="Symbol" pitchFamily="18" charset="2"/>
               </a:rPr>
-            </a:br>
-            <a:r>
-              <a:rPr lang="en-US" sz="2800" dirty="0">
+              <a:t>This is expressive enough, tough pre- and post-conditions may not, arguably, naturally capture inter-method interactions.</a:t>
+            </a:r>
+          </a:p>
+          <a:p>
+            <a:pPr lvl="1" eaLnBrk="1" hangingPunct="1"/>
+            <a:r>
+              <a:rPr lang="en-US" sz="2400" dirty="0">
                 <a:sym typeface="Symbol" pitchFamily="18" charset="2"/>
               </a:rPr>
-              <a:t>This is expressive enough, tough pre- and post-conditions do not, arguably, naturally capture inter-method interactions.</a:t>
+              <a:t>May need to access private fields. Also, directly testing private methods via their pre-/post is an issue.</a:t>
             </a:r>
           </a:p>
         </p:txBody>

</xml_diff>